<commit_message>
docs(whats-new): add Computer Use and MoA to overview and deck
</commit_message>
<xml_diff>
--- a/docs-michael/whats-new/whats-new-2-slides.pptx
+++ b/docs-michael/whats-new/whats-new-2-slides.pptx
@@ -3152,7 +3152,7 @@
                   <a:srgbClr val="2F6FED"/>
                 </a:solidFill>
               </a:rPr>
-              <a:t>Three big things - and a lot more.</a:t>
+              <a:t>Four big things - and a lot more.</a:t>
             </a:r>
           </a:p>
         </p:txBody>
@@ -3185,7 +3185,7 @@
                   <a:srgbClr val="1F2A37"/>
                 </a:solidFill>
               </a:rPr>
-              <a:t>The three big things</a:t>
+              <a:t>The big things</a:t>
             </a:r>
           </a:p>
           <a:p>
@@ -3206,6 +3206,16 @@
                 </a:solidFill>
               </a:rPr>
               <a:t>Third-party agents as team members - bring your own agent (Claude Code, Codex, DeepSeek Harness) through one standard plug.</a:t>
+            </a:r>
+          </a:p>
+          <a:p>
+            <a:r>
+              <a:rPr sz="1400" b="0" i="0">
+                <a:solidFill>
+                  <a:srgbClr val="1F2A37"/>
+                </a:solidFill>
+              </a:rPr>
+              <a:t>Computer Use - drives the whole desktop with real mouse and keyboard (Windows / macOS).</a:t>
             </a:r>
           </a:p>
           <a:p>
@@ -3229,7 +3239,7 @@
         <p:spPr>
           <a:xfrm>
             <a:off x="640080" y="3794760"/>
-            <a:ext cx="6021978" cy="1477328"/>
+            <a:ext cx="6021978" cy="1629728"/>
           </a:xfrm>
           <a:prstGeom prst="rect">
             <a:avLst/>
@@ -3325,6 +3335,16 @@
                 </a:solidFill>
               </a:rPr>
               <a:t> - one search across skills, experts and plugins.</a:t>
+            </a:r>
+          </a:p>
+          <a:p>
+            <a:r>
+              <a:rPr sz="1200" b="0" i="0" dirty="0">
+                <a:solidFill>
+                  <a:srgbClr val="555F6D"/>
+                </a:solidFill>
+              </a:rPr>
+              <a:t>Multi-model collaboration (MoA) - several models answer at once; a verifier routes progress.</a:t>
             </a:r>
           </a:p>
         </p:txBody>

</xml_diff>